<commit_message>
Adding cover sheet and polishing report
Adding cover sheet and detaling report
</commit_message>
<xml_diff>
--- a/Presentation/Presentation.pptx
+++ b/Presentation/Presentation.pptx
@@ -297,8 +297,7 @@
 <file path=ppt/revisionInfo.xml><?xml version="1.0" encoding="utf-8"?>
 <p1510:revInfo xmlns:a="http://schemas.openxmlformats.org/drawingml/2006/main" xmlns:r="http://schemas.openxmlformats.org/officeDocument/2006/relationships" xmlns:p1510="http://schemas.microsoft.com/office/powerpoint/2015/10/main">
   <p1510:revLst>
-    <p1510:client id="{88F1E1E0-D463-4661-AD2E-C649CA6CAA8D}" v="28" dt="2026-05-29T20:52:26.990"/>
-    <p1510:client id="{9F14503F-80CE-4341-8F83-3A320F84DD3E}" v="14" dt="2026-05-28T22:26:09.902"/>
+    <p1510:client id="{88F1E1E0-D463-4661-AD2E-C649CA6CAA8D}" v="29" dt="2026-05-30T13:37:59.836"/>
   </p1510:revLst>
 </p1510:revInfo>
 </file>
@@ -308,18 +307,18 @@
   <pc:docChgLst>
     <pc:chgData name="Sander Soares" userId="670adff8fbebcc24" providerId="LiveId" clId="{E0F74DC6-1A43-432B-BC72-B2CD7B95C7BA}"/>
     <pc:docChg chg="undo custSel addSld delSld modSld sldOrd delMainMaster">
-      <pc:chgData name="Sander Soares" userId="670adff8fbebcc24" providerId="LiveId" clId="{E0F74DC6-1A43-432B-BC72-B2CD7B95C7BA}" dt="2026-05-29T20:58:04.543" v="3741" actId="1076"/>
+      <pc:chgData name="Sander Soares" userId="670adff8fbebcc24" providerId="LiveId" clId="{E0F74DC6-1A43-432B-BC72-B2CD7B95C7BA}" dt="2026-05-30T13:45:24.640" v="3768" actId="1076"/>
       <pc:docMkLst>
         <pc:docMk/>
       </pc:docMkLst>
       <pc:sldChg chg="modSp mod">
-        <pc:chgData name="Sander Soares" userId="670adff8fbebcc24" providerId="LiveId" clId="{E0F74DC6-1A43-432B-BC72-B2CD7B95C7BA}" dt="2026-05-29T20:14:01.424" v="2678" actId="1076"/>
+        <pc:chgData name="Sander Soares" userId="670adff8fbebcc24" providerId="LiveId" clId="{E0F74DC6-1A43-432B-BC72-B2CD7B95C7BA}" dt="2026-05-30T13:45:14.593" v="3767" actId="1076"/>
         <pc:sldMkLst>
           <pc:docMk/>
           <pc:sldMk cId="0" sldId="256"/>
         </pc:sldMkLst>
         <pc:spChg chg="mod">
-          <ac:chgData name="Sander Soares" userId="670adff8fbebcc24" providerId="LiveId" clId="{E0F74DC6-1A43-432B-BC72-B2CD7B95C7BA}" dt="2026-05-29T20:13:52.108" v="2676" actId="1076"/>
+          <ac:chgData name="Sander Soares" userId="670adff8fbebcc24" providerId="LiveId" clId="{E0F74DC6-1A43-432B-BC72-B2CD7B95C7BA}" dt="2026-05-30T13:45:14.593" v="3767" actId="1076"/>
           <ac:spMkLst>
             <pc:docMk/>
             <pc:sldMk cId="0" sldId="256"/>
@@ -327,7 +326,7 @@
           </ac:spMkLst>
         </pc:spChg>
         <pc:spChg chg="mod">
-          <ac:chgData name="Sander Soares" userId="670adff8fbebcc24" providerId="LiveId" clId="{E0F74DC6-1A43-432B-BC72-B2CD7B95C7BA}" dt="2026-05-29T20:13:55.990" v="2677" actId="1076"/>
+          <ac:chgData name="Sander Soares" userId="670adff8fbebcc24" providerId="LiveId" clId="{E0F74DC6-1A43-432B-BC72-B2CD7B95C7BA}" dt="2026-05-30T13:44:46.110" v="3766" actId="1076"/>
           <ac:spMkLst>
             <pc:docMk/>
             <pc:sldMk cId="0" sldId="256"/>
@@ -831,7 +830,7 @@
         </pc:spChg>
       </pc:sldChg>
       <pc:sldChg chg="addSp delSp modSp add mod">
-        <pc:chgData name="Sander Soares" userId="670adff8fbebcc24" providerId="LiveId" clId="{E0F74DC6-1A43-432B-BC72-B2CD7B95C7BA}" dt="2026-05-29T20:51:04.356" v="3709" actId="1076"/>
+        <pc:chgData name="Sander Soares" userId="670adff8fbebcc24" providerId="LiveId" clId="{E0F74DC6-1A43-432B-BC72-B2CD7B95C7BA}" dt="2026-05-30T13:36:10.662" v="3745" actId="1076"/>
         <pc:sldMkLst>
           <pc:docMk/>
           <pc:sldMk cId="2014671674" sldId="315"/>
@@ -893,7 +892,7 @@
           </ac:graphicFrameMkLst>
         </pc:graphicFrameChg>
         <pc:picChg chg="add mod">
-          <ac:chgData name="Sander Soares" userId="670adff8fbebcc24" providerId="LiveId" clId="{E0F74DC6-1A43-432B-BC72-B2CD7B95C7BA}" dt="2026-05-29T19:37:21.833" v="1785" actId="14100"/>
+          <ac:chgData name="Sander Soares" userId="670adff8fbebcc24" providerId="LiveId" clId="{E0F74DC6-1A43-432B-BC72-B2CD7B95C7BA}" dt="2026-05-30T13:36:10.662" v="3745" actId="1076"/>
           <ac:picMkLst>
             <pc:docMk/>
             <pc:sldMk cId="2014671674" sldId="315"/>
@@ -901,7 +900,7 @@
           </ac:picMkLst>
         </pc:picChg>
         <pc:picChg chg="add mod">
-          <ac:chgData name="Sander Soares" userId="670adff8fbebcc24" providerId="LiveId" clId="{E0F74DC6-1A43-432B-BC72-B2CD7B95C7BA}" dt="2026-05-29T19:37:24.683" v="1787" actId="14100"/>
+          <ac:chgData name="Sander Soares" userId="670adff8fbebcc24" providerId="LiveId" clId="{E0F74DC6-1A43-432B-BC72-B2CD7B95C7BA}" dt="2026-05-30T13:36:08.264" v="3744" actId="1076"/>
           <ac:picMkLst>
             <pc:docMk/>
             <pc:sldMk cId="2014671674" sldId="315"/>
@@ -909,7 +908,7 @@
           </ac:picMkLst>
         </pc:picChg>
         <pc:picChg chg="add mod">
-          <ac:chgData name="Sander Soares" userId="670adff8fbebcc24" providerId="LiveId" clId="{E0F74DC6-1A43-432B-BC72-B2CD7B95C7BA}" dt="2026-05-29T19:37:30.463" v="1790" actId="14100"/>
+          <ac:chgData name="Sander Soares" userId="670adff8fbebcc24" providerId="LiveId" clId="{E0F74DC6-1A43-432B-BC72-B2CD7B95C7BA}" dt="2026-05-30T13:36:06.661" v="3743" actId="1076"/>
           <ac:picMkLst>
             <pc:docMk/>
             <pc:sldMk cId="2014671674" sldId="315"/>
@@ -917,12 +916,28 @@
           </ac:picMkLst>
         </pc:picChg>
       </pc:sldChg>
-      <pc:sldChg chg="modSp add mod">
-        <pc:chgData name="Sander Soares" userId="670adff8fbebcc24" providerId="LiveId" clId="{E0F74DC6-1A43-432B-BC72-B2CD7B95C7BA}" dt="2026-05-29T20:52:32.018" v="3715" actId="20577"/>
+      <pc:sldChg chg="addSp delSp modSp add mod">
+        <pc:chgData name="Sander Soares" userId="670adff8fbebcc24" providerId="LiveId" clId="{E0F74DC6-1A43-432B-BC72-B2CD7B95C7BA}" dt="2026-05-30T13:40:53.883" v="3764" actId="478"/>
         <pc:sldMkLst>
           <pc:docMk/>
           <pc:sldMk cId="2508334252" sldId="316"/>
         </pc:sldMkLst>
+        <pc:spChg chg="add mod">
+          <ac:chgData name="Sander Soares" userId="670adff8fbebcc24" providerId="LiveId" clId="{E0F74DC6-1A43-432B-BC72-B2CD7B95C7BA}" dt="2026-05-30T13:40:47.703" v="3763" actId="1076"/>
+          <ac:spMkLst>
+            <pc:docMk/>
+            <pc:sldMk cId="2508334252" sldId="316"/>
+            <ac:spMk id="2" creationId="{45C2114F-290A-055E-DD1C-7E060075AC91}"/>
+          </ac:spMkLst>
+        </pc:spChg>
+        <pc:spChg chg="add del mod">
+          <ac:chgData name="Sander Soares" userId="670adff8fbebcc24" providerId="LiveId" clId="{E0F74DC6-1A43-432B-BC72-B2CD7B95C7BA}" dt="2026-05-30T13:40:53.883" v="3764" actId="478"/>
+          <ac:spMkLst>
+            <pc:docMk/>
+            <pc:sldMk cId="2508334252" sldId="316"/>
+            <ac:spMk id="4" creationId="{A3E2CDEA-3320-1371-2263-678BE81D57FE}"/>
+          </ac:spMkLst>
+        </pc:spChg>
         <pc:spChg chg="mod">
           <ac:chgData name="Sander Soares" userId="670adff8fbebcc24" providerId="LiveId" clId="{E0F74DC6-1A43-432B-BC72-B2CD7B95C7BA}" dt="2026-05-26T15:06:21.115" v="1746" actId="1076"/>
           <ac:spMkLst>
@@ -940,7 +955,7 @@
           </ac:spMkLst>
         </pc:spChg>
         <pc:picChg chg="mod">
-          <ac:chgData name="Sander Soares" userId="670adff8fbebcc24" providerId="LiveId" clId="{E0F74DC6-1A43-432B-BC72-B2CD7B95C7BA}" dt="2026-05-29T20:51:15.970" v="3711" actId="1076"/>
+          <ac:chgData name="Sander Soares" userId="670adff8fbebcc24" providerId="LiveId" clId="{E0F74DC6-1A43-432B-BC72-B2CD7B95C7BA}" dt="2026-05-30T13:38:53.424" v="3755" actId="1076"/>
           <ac:picMkLst>
             <pc:docMk/>
             <pc:sldMk cId="2508334252" sldId="316"/>
@@ -949,7 +964,7 @@
         </pc:picChg>
       </pc:sldChg>
       <pc:sldChg chg="addSp delSp modSp add mod">
-        <pc:chgData name="Sander Soares" userId="670adff8fbebcc24" providerId="LiveId" clId="{E0F74DC6-1A43-432B-BC72-B2CD7B95C7BA}" dt="2026-05-29T20:52:56.546" v="3719" actId="6549"/>
+        <pc:chgData name="Sander Soares" userId="670adff8fbebcc24" providerId="LiveId" clId="{E0F74DC6-1A43-432B-BC72-B2CD7B95C7BA}" dt="2026-05-30T13:34:29.649" v="3742" actId="1076"/>
         <pc:sldMkLst>
           <pc:docMk/>
           <pc:sldMk cId="3118840847" sldId="317"/>
@@ -1003,7 +1018,7 @@
           </ac:spMkLst>
         </pc:spChg>
         <pc:spChg chg="add mod">
-          <ac:chgData name="Sander Soares" userId="670adff8fbebcc24" providerId="LiveId" clId="{E0F74DC6-1A43-432B-BC72-B2CD7B95C7BA}" dt="2026-05-29T20:52:56.546" v="3719" actId="6549"/>
+          <ac:chgData name="Sander Soares" userId="670adff8fbebcc24" providerId="LiveId" clId="{E0F74DC6-1A43-432B-BC72-B2CD7B95C7BA}" dt="2026-05-30T13:34:29.649" v="3742" actId="1076"/>
           <ac:spMkLst>
             <pc:docMk/>
             <pc:sldMk cId="3118840847" sldId="317"/>
@@ -1099,13 +1114,13 @@
         </pc:spChg>
       </pc:sldChg>
       <pc:sldChg chg="addSp delSp modSp add mod ord modClrScheme chgLayout">
-        <pc:chgData name="Sander Soares" userId="670adff8fbebcc24" providerId="LiveId" clId="{E0F74DC6-1A43-432B-BC72-B2CD7B95C7BA}" dt="2026-05-29T20:46:50.074" v="3579" actId="207"/>
+        <pc:chgData name="Sander Soares" userId="670adff8fbebcc24" providerId="LiveId" clId="{E0F74DC6-1A43-432B-BC72-B2CD7B95C7BA}" dt="2026-05-30T13:45:24.640" v="3768" actId="1076"/>
         <pc:sldMkLst>
           <pc:docMk/>
           <pc:sldMk cId="1527386263" sldId="319"/>
         </pc:sldMkLst>
         <pc:spChg chg="add mod">
-          <ac:chgData name="Sander Soares" userId="670adff8fbebcc24" providerId="LiveId" clId="{E0F74DC6-1A43-432B-BC72-B2CD7B95C7BA}" dt="2026-05-29T20:46:50.074" v="3579" actId="207"/>
+          <ac:chgData name="Sander Soares" userId="670adff8fbebcc24" providerId="LiveId" clId="{E0F74DC6-1A43-432B-BC72-B2CD7B95C7BA}" dt="2026-05-30T13:45:24.640" v="3768" actId="1076"/>
           <ac:spMkLst>
             <pc:docMk/>
             <pc:sldMk cId="1527386263" sldId="319"/>
@@ -1121,7 +1136,7 @@
           </ac:spMkLst>
         </pc:spChg>
         <pc:spChg chg="add mod">
-          <ac:chgData name="Sander Soares" userId="670adff8fbebcc24" providerId="LiveId" clId="{E0F74DC6-1A43-432B-BC72-B2CD7B95C7BA}" dt="2026-05-29T20:46:40.088" v="3577" actId="1076"/>
+          <ac:chgData name="Sander Soares" userId="670adff8fbebcc24" providerId="LiveId" clId="{E0F74DC6-1A43-432B-BC72-B2CD7B95C7BA}" dt="2026-05-30T13:45:24.640" v="3768" actId="1076"/>
           <ac:spMkLst>
             <pc:docMk/>
             <pc:sldMk cId="1527386263" sldId="319"/>
@@ -1438,44 +1453,12 @@
           <pc:docMk/>
           <pc:sldMk cId="0" sldId="257"/>
         </pc:sldMkLst>
-        <pc:spChg chg="add del mod">
-          <ac:chgData name="Thiago Gonçalves" userId="e211bf435202b616" providerId="LiveId" clId="{59053E26-0135-52D3-A65E-BE91A54E195B}" dt="2026-05-28T21:49:43.519" v="133" actId="478"/>
-          <ac:spMkLst>
-            <pc:docMk/>
-            <pc:sldMk cId="0" sldId="257"/>
-            <ac:spMk id="3" creationId="{4CF27028-9365-5CDA-60C5-A8390F805382}"/>
-          </ac:spMkLst>
-        </pc:spChg>
         <pc:spChg chg="mod">
           <ac:chgData name="Thiago Gonçalves" userId="e211bf435202b616" providerId="LiveId" clId="{59053E26-0135-52D3-A65E-BE91A54E195B}" dt="2026-05-28T21:51:25.375" v="195" actId="1037"/>
           <ac:spMkLst>
             <pc:docMk/>
             <pc:sldMk cId="0" sldId="257"/>
             <ac:spMk id="796" creationId="{00000000-0000-0000-0000-000000000000}"/>
-          </ac:spMkLst>
-        </pc:spChg>
-        <pc:spChg chg="del">
-          <ac:chgData name="Thiago Gonçalves" userId="e211bf435202b616" providerId="LiveId" clId="{59053E26-0135-52D3-A65E-BE91A54E195B}" dt="2026-05-28T21:49:40.872" v="132" actId="478"/>
-          <ac:spMkLst>
-            <pc:docMk/>
-            <pc:sldMk cId="0" sldId="257"/>
-            <ac:spMk id="797" creationId="{00000000-0000-0000-0000-000000000000}"/>
-          </ac:spMkLst>
-        </pc:spChg>
-        <pc:spChg chg="add del">
-          <ac:chgData name="Thiago Gonçalves" userId="e211bf435202b616" providerId="LiveId" clId="{59053E26-0135-52D3-A65E-BE91A54E195B}" dt="2026-05-28T21:48:40.719" v="124" actId="478"/>
-          <ac:spMkLst>
-            <pc:docMk/>
-            <pc:sldMk cId="0" sldId="257"/>
-            <ac:spMk id="798" creationId="{00000000-0000-0000-0000-000000000000}"/>
-          </ac:spMkLst>
-        </pc:spChg>
-        <pc:spChg chg="add del">
-          <ac:chgData name="Thiago Gonçalves" userId="e211bf435202b616" providerId="LiveId" clId="{59053E26-0135-52D3-A65E-BE91A54E195B}" dt="2026-05-28T21:48:42.022" v="125" actId="478"/>
-          <ac:spMkLst>
-            <pc:docMk/>
-            <pc:sldMk cId="0" sldId="257"/>
-            <ac:spMk id="799" creationId="{00000000-0000-0000-0000-000000000000}"/>
           </ac:spMkLst>
         </pc:spChg>
         <pc:graphicFrameChg chg="add del mod modGraphic">
@@ -1501,22 +1484,6 @@
             <ac:spMk id="797" creationId="{06221550-99F0-9AA7-F6BF-11827C750B47}"/>
           </ac:spMkLst>
         </pc:spChg>
-        <pc:spChg chg="del">
-          <ac:chgData name="Thiago Gonçalves" userId="e211bf435202b616" providerId="LiveId" clId="{59053E26-0135-52D3-A65E-BE91A54E195B}" dt="2026-05-28T22:12:27.294" v="312" actId="478"/>
-          <ac:spMkLst>
-            <pc:docMk/>
-            <pc:sldMk cId="2760449867" sldId="314"/>
-            <ac:spMk id="798" creationId="{9CD58AD5-6E46-0294-35E2-5AE41472148D}"/>
-          </ac:spMkLst>
-        </pc:spChg>
-        <pc:spChg chg="del mod">
-          <ac:chgData name="Thiago Gonçalves" userId="e211bf435202b616" providerId="LiveId" clId="{59053E26-0135-52D3-A65E-BE91A54E195B}" dt="2026-05-28T22:12:31.102" v="314" actId="478"/>
-          <ac:spMkLst>
-            <pc:docMk/>
-            <pc:sldMk cId="2760449867" sldId="314"/>
-            <ac:spMk id="799" creationId="{23BF158E-776C-7733-7812-472EEE092795}"/>
-          </ac:spMkLst>
-        </pc:spChg>
         <pc:graphicFrameChg chg="mod modGraphic">
           <ac:chgData name="Thiago Gonçalves" userId="e211bf435202b616" providerId="LiveId" clId="{59053E26-0135-52D3-A65E-BE91A54E195B}" dt="2026-05-28T22:19:05.580" v="448" actId="1076"/>
           <ac:graphicFrameMkLst>
@@ -1540,30 +1507,6 @@
             <ac:spMk id="797" creationId="{8066FBAD-1FE1-0D20-C81E-8BBBF2A7D29B}"/>
           </ac:spMkLst>
         </pc:spChg>
-        <pc:spChg chg="del">
-          <ac:chgData name="Thiago Gonçalves" userId="e211bf435202b616" providerId="LiveId" clId="{59053E26-0135-52D3-A65E-BE91A54E195B}" dt="2026-05-28T22:26:06.020" v="453" actId="478"/>
-          <ac:spMkLst>
-            <pc:docMk/>
-            <pc:sldMk cId="2508334252" sldId="316"/>
-            <ac:spMk id="798" creationId="{8EFB9E9C-2456-6978-C626-9DF46F020045}"/>
-          </ac:spMkLst>
-        </pc:spChg>
-        <pc:spChg chg="del">
-          <ac:chgData name="Thiago Gonçalves" userId="e211bf435202b616" providerId="LiveId" clId="{59053E26-0135-52D3-A65E-BE91A54E195B}" dt="2026-05-28T22:26:07.864" v="454" actId="478"/>
-          <ac:spMkLst>
-            <pc:docMk/>
-            <pc:sldMk cId="2508334252" sldId="316"/>
-            <ac:spMk id="799" creationId="{AC315DF1-4B28-9B1A-3E19-382A3F491604}"/>
-          </ac:spMkLst>
-        </pc:spChg>
-        <pc:graphicFrameChg chg="del">
-          <ac:chgData name="Thiago Gonçalves" userId="e211bf435202b616" providerId="LiveId" clId="{59053E26-0135-52D3-A65E-BE91A54E195B}" dt="2026-05-28T22:25:57.725" v="452" actId="478"/>
-          <ac:graphicFrameMkLst>
-            <pc:docMk/>
-            <pc:sldMk cId="2508334252" sldId="316"/>
-            <ac:graphicFrameMk id="800" creationId="{F3A56D1A-13DD-433A-C5A5-79708514E7AD}"/>
-          </ac:graphicFrameMkLst>
-        </pc:graphicFrameChg>
         <pc:picChg chg="add mod">
           <ac:chgData name="Thiago Gonçalves" userId="e211bf435202b616" providerId="LiveId" clId="{59053E26-0135-52D3-A65E-BE91A54E195B}" dt="2026-05-28T22:31:34.586" v="509" actId="1076"/>
           <ac:picMkLst>
@@ -8263,7 +8206,7 @@
         </p:nvSpPr>
         <p:spPr>
           <a:xfrm>
-            <a:off x="3301235" y="3579851"/>
+            <a:off x="3301235" y="3740523"/>
             <a:ext cx="2541529" cy="387300"/>
           </a:xfrm>
           <a:prstGeom prst="rect">
@@ -8320,7 +8263,7 @@
         </p:nvSpPr>
         <p:spPr>
           <a:xfrm>
-            <a:off x="530225" y="1724866"/>
+            <a:off x="551007" y="1801002"/>
             <a:ext cx="8337621" cy="1973219"/>
           </a:xfrm>
           <a:prstGeom prst="rect">
@@ -12491,7 +12434,7 @@
         </p:nvSpPr>
         <p:spPr>
           <a:xfrm>
-            <a:off x="3419337" y="1175017"/>
+            <a:off x="3479476" y="1513160"/>
             <a:ext cx="3151583" cy="1681425"/>
           </a:xfrm>
           <a:prstGeom prst="rect">
@@ -12911,7 +12854,7 @@
         </p:nvSpPr>
         <p:spPr>
           <a:xfrm>
-            <a:off x="3338945" y="785807"/>
+            <a:off x="3399084" y="1123950"/>
             <a:ext cx="3311237" cy="2137502"/>
           </a:xfrm>
           <a:prstGeom prst="rect">
@@ -14424,7 +14367,7 @@
         </p:blipFill>
         <p:spPr>
           <a:xfrm>
-            <a:off x="13854" y="572700"/>
+            <a:off x="27708" y="572700"/>
             <a:ext cx="5334001" cy="1421246"/>
           </a:xfrm>
           <a:prstGeom prst="rect">
@@ -14460,7 +14403,7 @@
         </p:blipFill>
         <p:spPr>
           <a:xfrm>
-            <a:off x="6928" y="2112350"/>
+            <a:off x="20781" y="2112350"/>
             <a:ext cx="5340928" cy="1335405"/>
           </a:xfrm>
           <a:prstGeom prst="rect">
@@ -14496,7 +14439,7 @@
         </p:blipFill>
         <p:spPr>
           <a:xfrm>
-            <a:off x="0" y="3566159"/>
+            <a:off x="13854" y="3566159"/>
             <a:ext cx="5347855" cy="1371600"/>
           </a:xfrm>
           <a:prstGeom prst="rect">
@@ -15112,13 +15055,65 @@
         <p:spPr>
           <a:xfrm>
             <a:off x="4971705" y="1007906"/>
-            <a:ext cx="4089168" cy="3273148"/>
+            <a:ext cx="4089168" cy="3388558"/>
           </a:xfrm>
           <a:prstGeom prst="rect">
             <a:avLst/>
           </a:prstGeom>
         </p:spPr>
       </p:pic>
+      <p:sp>
+        <p:nvSpPr>
+          <p:cNvPr id="2" name="Rectangle 1">
+            <a:extLst>
+              <a:ext uri="{FF2B5EF4-FFF2-40B4-BE49-F238E27FC236}">
+                <a16:creationId xmlns:a16="http://schemas.microsoft.com/office/drawing/2014/main" id="{45C2114F-290A-055E-DD1C-7E060075AC91}"/>
+              </a:ext>
+            </a:extLst>
+          </p:cNvPr>
+          <p:cNvSpPr/>
+          <p:nvPr/>
+        </p:nvSpPr>
+        <p:spPr>
+          <a:xfrm>
+            <a:off x="4971705" y="2003392"/>
+            <a:ext cx="4089168" cy="187037"/>
+          </a:xfrm>
+          <a:prstGeom prst="rect">
+            <a:avLst/>
+          </a:prstGeom>
+          <a:noFill/>
+          <a:ln>
+            <a:solidFill>
+              <a:srgbClr val="C00000"/>
+            </a:solidFill>
+          </a:ln>
+        </p:spPr>
+        <p:style>
+          <a:lnRef idx="2">
+            <a:schemeClr val="accent1">
+              <a:shade val="15000"/>
+            </a:schemeClr>
+          </a:lnRef>
+          <a:fillRef idx="1">
+            <a:schemeClr val="accent1"/>
+          </a:fillRef>
+          <a:effectRef idx="0">
+            <a:schemeClr val="accent1"/>
+          </a:effectRef>
+          <a:fontRef idx="minor">
+            <a:schemeClr val="lt1"/>
+          </a:fontRef>
+        </p:style>
+        <p:txBody>
+          <a:bodyPr rtlCol="0" anchor="ctr"/>
+          <a:lstStyle/>
+          <a:p>
+            <a:pPr algn="ctr"/>
+            <a:endParaRPr lang="en-IE"/>
+          </a:p>
+        </p:txBody>
+      </p:sp>
     </p:spTree>
     <p:extLst>
       <p:ext uri="{BB962C8B-B14F-4D97-AF65-F5344CB8AC3E}">
@@ -16360,7 +16355,7 @@
         </p:nvSpPr>
         <p:spPr>
           <a:xfrm>
-            <a:off x="0" y="3752232"/>
+            <a:off x="51954" y="3730965"/>
             <a:ext cx="3993572" cy="1338828"/>
           </a:xfrm>
           <a:prstGeom prst="rect">

</xml_diff>